<commit_message>
Fix slides 5-7: replace screenshot overlays with side-panel callouts
Callout boxes were overlapping the screenshot at the top. Replaced with
a clean two-column layout: screenshot fills left 8.4", right panel holds
6 highlight bullets in dark cards with orange accent strips.

Co-Authored-By: Claude Sonnet 4.6 <noreply@anthropic.com>
</commit_message>
<xml_diff>
--- a/AWS_Features_Tracker_Innovation_Demo.pptx
+++ b/AWS_Features_Tracker_Innovation_Demo.pptx
@@ -14724,8 +14724,8 @@
         </p:nvSpPr>
         <p:spPr>
           <a:xfrm>
-            <a:off x="502920" y="384048"/>
-            <a:ext cx="8686800" cy="457200"/>
+            <a:off x="320040" y="274320"/>
+            <a:ext cx="8686800" cy="475488"/>
           </a:xfrm>
           <a:prstGeom prst="rect">
             <a:avLst/>
@@ -14740,7 +14740,7 @@
           <a:p>
             <a:pPr algn="l"/>
             <a:r>
-              <a:rPr sz="2200" b="1" i="0">
+              <a:rPr sz="2000" b="1" i="0">
                 <a:solidFill>
                   <a:srgbClr val="FFFFFF"/>
                 </a:solidFill>
@@ -14766,8 +14766,8 @@
         </p:blipFill>
         <p:spPr>
           <a:xfrm>
-            <a:off x="320040" y="896112"/>
-            <a:ext cx="11539728" cy="5486400"/>
+            <a:off x="320040" y="841248"/>
+            <a:ext cx="7662672" cy="5907024"/>
           </a:xfrm>
           <a:prstGeom prst="rect">
             <a:avLst/>
@@ -14782,14 +14782,14 @@
         </p:nvSpPr>
         <p:spPr>
           <a:xfrm>
-            <a:off x="347472" y="932688"/>
-            <a:ext cx="2606040" cy="292608"/>
-          </a:xfrm>
-          <a:prstGeom prst="rect">
-            <a:avLst/>
-          </a:prstGeom>
-          <a:solidFill>
-            <a:srgbClr val="0D1A26"/>
+            <a:off x="8092440" y="841248"/>
+            <a:ext cx="2852928" cy="5907024"/>
+          </a:xfrm>
+          <a:prstGeom prst="rect">
+            <a:avLst/>
+          </a:prstGeom>
+          <a:solidFill>
+            <a:srgbClr val="0D1A2E"/>
           </a:solidFill>
           <a:ln>
             <a:noFill/>
@@ -14819,14 +14819,57 @@
       </p:sp>
       <p:sp>
         <p:nvSpPr>
-          <p:cNvPr id="8" name="TextBox 7"/>
+          <p:cNvPr id="8" name="Rectangle 7"/>
+          <p:cNvSpPr/>
+          <p:nvPr/>
+        </p:nvSpPr>
+        <p:spPr>
+          <a:xfrm>
+            <a:off x="8092440" y="841248"/>
+            <a:ext cx="54864" cy="5907024"/>
+          </a:xfrm>
+          <a:prstGeom prst="rect">
+            <a:avLst/>
+          </a:prstGeom>
+          <a:solidFill>
+            <a:srgbClr val="FF9900"/>
+          </a:solidFill>
+          <a:ln>
+            <a:noFill/>
+          </a:ln>
+        </p:spPr>
+        <p:style>
+          <a:lnRef idx="1">
+            <a:schemeClr val="accent1"/>
+          </a:lnRef>
+          <a:fillRef idx="3">
+            <a:schemeClr val="accent1"/>
+          </a:fillRef>
+          <a:effectRef idx="2">
+            <a:schemeClr val="accent1"/>
+          </a:effectRef>
+          <a:fontRef idx="minor">
+            <a:schemeClr val="lt1"/>
+          </a:fontRef>
+        </p:style>
+        <p:txBody>
+          <a:bodyPr rtlCol="0" anchor="ctr"/>
+          <a:lstStyle/>
+          <a:p>
+            <a:pPr algn="ctr"/>
+          </a:p>
+        </p:txBody>
+      </p:sp>
+      <p:sp>
+        <p:nvSpPr>
+          <p:cNvPr id="9" name="TextBox 8"/>
           <p:cNvSpPr txBox="1"/>
           <p:nvPr/>
         </p:nvSpPr>
         <p:spPr>
           <a:xfrm>
-            <a:off x="420624" y="978408"/>
-            <a:ext cx="2487168" cy="219456"/>
+            <a:off x="8257032" y="1005840"/>
+            <a:ext cx="2596896" cy="256032"/>
           </a:xfrm>
           <a:prstGeom prst="rect">
             <a:avLst/>
@@ -14841,32 +14884,32 @@
           <a:p>
             <a:pPr algn="l"/>
             <a:r>
-              <a:rPr sz="900" b="0" i="0">
+              <a:rPr sz="800" b="1" i="0">
                 <a:solidFill>
                   <a:srgbClr val="FF9900"/>
                 </a:solidFill>
               </a:rPr>
-              <a:t>▶  Live search with 300ms debounce</a:t>
-            </a:r>
-          </a:p>
-        </p:txBody>
-      </p:sp>
-      <p:sp>
-        <p:nvSpPr>
-          <p:cNvPr id="9" name="Rectangle 8"/>
-          <p:cNvSpPr/>
-          <p:nvPr/>
-        </p:nvSpPr>
-        <p:spPr>
-          <a:xfrm>
-            <a:off x="347472" y="1335024"/>
-            <a:ext cx="2606040" cy="292608"/>
-          </a:xfrm>
-          <a:prstGeom prst="rect">
-            <a:avLst/>
-          </a:prstGeom>
-          <a:solidFill>
-            <a:srgbClr val="0D1A26"/>
+              <a:t>KEY HIGHLIGHTS</a:t>
+            </a:r>
+          </a:p>
+        </p:txBody>
+      </p:sp>
+      <p:sp>
+        <p:nvSpPr>
+          <p:cNvPr id="10" name="Rectangle 9"/>
+          <p:cNvSpPr/>
+          <p:nvPr/>
+        </p:nvSpPr>
+        <p:spPr>
+          <a:xfrm>
+            <a:off x="8257032" y="1371600"/>
+            <a:ext cx="2596896" cy="749808"/>
+          </a:xfrm>
+          <a:prstGeom prst="rect">
+            <a:avLst/>
+          </a:prstGeom>
+          <a:solidFill>
+            <a:srgbClr val="1A2A3E"/>
           </a:solidFill>
           <a:ln>
             <a:noFill/>
@@ -14896,14 +14939,57 @@
       </p:sp>
       <p:sp>
         <p:nvSpPr>
-          <p:cNvPr id="10" name="TextBox 9"/>
+          <p:cNvPr id="11" name="Rectangle 10"/>
+          <p:cNvSpPr/>
+          <p:nvPr/>
+        </p:nvSpPr>
+        <p:spPr>
+          <a:xfrm>
+            <a:off x="8257032" y="1371600"/>
+            <a:ext cx="36576" cy="749808"/>
+          </a:xfrm>
+          <a:prstGeom prst="rect">
+            <a:avLst/>
+          </a:prstGeom>
+          <a:solidFill>
+            <a:srgbClr val="FF9900"/>
+          </a:solidFill>
+          <a:ln>
+            <a:noFill/>
+          </a:ln>
+        </p:spPr>
+        <p:style>
+          <a:lnRef idx="1">
+            <a:schemeClr val="accent1"/>
+          </a:lnRef>
+          <a:fillRef idx="3">
+            <a:schemeClr val="accent1"/>
+          </a:fillRef>
+          <a:effectRef idx="2">
+            <a:schemeClr val="accent1"/>
+          </a:effectRef>
+          <a:fontRef idx="minor">
+            <a:schemeClr val="lt1"/>
+          </a:fontRef>
+        </p:style>
+        <p:txBody>
+          <a:bodyPr rtlCol="0" anchor="ctr"/>
+          <a:lstStyle/>
+          <a:p>
+            <a:pPr algn="ctr"/>
+          </a:p>
+        </p:txBody>
+      </p:sp>
+      <p:sp>
+        <p:nvSpPr>
+          <p:cNvPr id="12" name="TextBox 11"/>
           <p:cNvSpPr txBox="1"/>
           <p:nvPr/>
         </p:nvSpPr>
         <p:spPr>
           <a:xfrm>
-            <a:off x="420624" y="1380744"/>
-            <a:ext cx="2487168" cy="219456"/>
+            <a:off x="8348472" y="1463040"/>
+            <a:ext cx="2468880" cy="594360"/>
           </a:xfrm>
           <a:prstGeom prst="rect">
             <a:avLst/>
@@ -14918,32 +15004,33 @@
           <a:p>
             <a:pPr algn="l"/>
             <a:r>
-              <a:rPr sz="900" b="0" i="0">
-                <a:solidFill>
-                  <a:srgbClr val="FF9900"/>
+              <a:rPr sz="1000" b="0" i="0">
+                <a:solidFill>
+                  <a:srgbClr val="E2E8F0"/>
                 </a:solidFill>
               </a:rPr>
-              <a:t>▶  Service / type / date / sort filters</a:t>
-            </a:r>
-          </a:p>
-        </p:txBody>
-      </p:sp>
-      <p:sp>
-        <p:nvSpPr>
-          <p:cNvPr id="11" name="Rectangle 10"/>
-          <p:cNvSpPr/>
-          <p:nvPr/>
-        </p:nvSpPr>
-        <p:spPr>
-          <a:xfrm>
-            <a:off x="347472" y="1737360"/>
-            <a:ext cx="2606040" cy="292608"/>
-          </a:xfrm>
-          <a:prstGeom prst="rect">
-            <a:avLst/>
-          </a:prstGeom>
-          <a:solidFill>
-            <a:srgbClr val="0D1A26"/>
+              <a:t>Live search bar
+with 300ms debounce</a:t>
+            </a:r>
+          </a:p>
+        </p:txBody>
+      </p:sp>
+      <p:sp>
+        <p:nvSpPr>
+          <p:cNvPr id="13" name="Rectangle 12"/>
+          <p:cNvSpPr/>
+          <p:nvPr/>
+        </p:nvSpPr>
+        <p:spPr>
+          <a:xfrm>
+            <a:off x="8257032" y="2231136"/>
+            <a:ext cx="2596896" cy="749808"/>
+          </a:xfrm>
+          <a:prstGeom prst="rect">
+            <a:avLst/>
+          </a:prstGeom>
+          <a:solidFill>
+            <a:srgbClr val="1A2A3E"/>
           </a:solidFill>
           <a:ln>
             <a:noFill/>
@@ -14973,14 +15060,57 @@
       </p:sp>
       <p:sp>
         <p:nvSpPr>
-          <p:cNvPr id="12" name="TextBox 11"/>
+          <p:cNvPr id="14" name="Rectangle 13"/>
+          <p:cNvSpPr/>
+          <p:nvPr/>
+        </p:nvSpPr>
+        <p:spPr>
+          <a:xfrm>
+            <a:off x="8257032" y="2231136"/>
+            <a:ext cx="36576" cy="749808"/>
+          </a:xfrm>
+          <a:prstGeom prst="rect">
+            <a:avLst/>
+          </a:prstGeom>
+          <a:solidFill>
+            <a:srgbClr val="FF9900"/>
+          </a:solidFill>
+          <a:ln>
+            <a:noFill/>
+          </a:ln>
+        </p:spPr>
+        <p:style>
+          <a:lnRef idx="1">
+            <a:schemeClr val="accent1"/>
+          </a:lnRef>
+          <a:fillRef idx="3">
+            <a:schemeClr val="accent1"/>
+          </a:fillRef>
+          <a:effectRef idx="2">
+            <a:schemeClr val="accent1"/>
+          </a:effectRef>
+          <a:fontRef idx="minor">
+            <a:schemeClr val="lt1"/>
+          </a:fontRef>
+        </p:style>
+        <p:txBody>
+          <a:bodyPr rtlCol="0" anchor="ctr"/>
+          <a:lstStyle/>
+          <a:p>
+            <a:pPr algn="ctr"/>
+          </a:p>
+        </p:txBody>
+      </p:sp>
+      <p:sp>
+        <p:nvSpPr>
+          <p:cNvPr id="15" name="TextBox 14"/>
           <p:cNvSpPr txBox="1"/>
           <p:nvPr/>
         </p:nvSpPr>
         <p:spPr>
           <a:xfrm>
-            <a:off x="420624" y="1783080"/>
-            <a:ext cx="2487168" cy="219456"/>
+            <a:off x="8348472" y="2322576"/>
+            <a:ext cx="2468880" cy="594360"/>
           </a:xfrm>
           <a:prstGeom prst="rect">
             <a:avLst/>
@@ -14995,32 +15125,33 @@
           <a:p>
             <a:pPr algn="l"/>
             <a:r>
-              <a:rPr sz="900" b="0" i="0">
-                <a:solidFill>
-                  <a:srgbClr val="FF9900"/>
+              <a:rPr sz="1000" b="0" i="0">
+                <a:solidFill>
+                  <a:srgbClr val="E2E8F0"/>
                 </a:solidFill>
               </a:rPr>
-              <a:t>▶  Result count always visible</a:t>
-            </a:r>
-          </a:p>
-        </p:txBody>
-      </p:sp>
-      <p:sp>
-        <p:nvSpPr>
-          <p:cNvPr id="13" name="Rectangle 12"/>
-          <p:cNvSpPr/>
-          <p:nvPr/>
-        </p:nvSpPr>
-        <p:spPr>
-          <a:xfrm>
-            <a:off x="8549640" y="932688"/>
-            <a:ext cx="2606040" cy="292608"/>
-          </a:xfrm>
-          <a:prstGeom prst="rect">
-            <a:avLst/>
-          </a:prstGeom>
-          <a:solidFill>
-            <a:srgbClr val="0D1A26"/>
+              <a:t>Filters: service,
+type, date, sort order</a:t>
+            </a:r>
+          </a:p>
+        </p:txBody>
+      </p:sp>
+      <p:sp>
+        <p:nvSpPr>
+          <p:cNvPr id="16" name="Rectangle 15"/>
+          <p:cNvSpPr/>
+          <p:nvPr/>
+        </p:nvSpPr>
+        <p:spPr>
+          <a:xfrm>
+            <a:off x="8257032" y="3090672"/>
+            <a:ext cx="2596896" cy="749808"/>
+          </a:xfrm>
+          <a:prstGeom prst="rect">
+            <a:avLst/>
+          </a:prstGeom>
+          <a:solidFill>
+            <a:srgbClr val="1A2A3E"/>
           </a:solidFill>
           <a:ln>
             <a:noFill/>
@@ -15050,14 +15181,57 @@
       </p:sp>
       <p:sp>
         <p:nvSpPr>
-          <p:cNvPr id="14" name="TextBox 13"/>
+          <p:cNvPr id="17" name="Rectangle 16"/>
+          <p:cNvSpPr/>
+          <p:nvPr/>
+        </p:nvSpPr>
+        <p:spPr>
+          <a:xfrm>
+            <a:off x="8257032" y="3090672"/>
+            <a:ext cx="36576" cy="749808"/>
+          </a:xfrm>
+          <a:prstGeom prst="rect">
+            <a:avLst/>
+          </a:prstGeom>
+          <a:solidFill>
+            <a:srgbClr val="FF9900"/>
+          </a:solidFill>
+          <a:ln>
+            <a:noFill/>
+          </a:ln>
+        </p:spPr>
+        <p:style>
+          <a:lnRef idx="1">
+            <a:schemeClr val="accent1"/>
+          </a:lnRef>
+          <a:fillRef idx="3">
+            <a:schemeClr val="accent1"/>
+          </a:fillRef>
+          <a:effectRef idx="2">
+            <a:schemeClr val="accent1"/>
+          </a:effectRef>
+          <a:fontRef idx="minor">
+            <a:schemeClr val="lt1"/>
+          </a:fontRef>
+        </p:style>
+        <p:txBody>
+          <a:bodyPr rtlCol="0" anchor="ctr"/>
+          <a:lstStyle/>
+          <a:p>
+            <a:pPr algn="ctr"/>
+          </a:p>
+        </p:txBody>
+      </p:sp>
+      <p:sp>
+        <p:nvSpPr>
+          <p:cNvPr id="18" name="TextBox 17"/>
           <p:cNvSpPr txBox="1"/>
           <p:nvPr/>
         </p:nvSpPr>
         <p:spPr>
           <a:xfrm>
-            <a:off x="8622792" y="978408"/>
-            <a:ext cx="2487168" cy="219456"/>
+            <a:off x="8348472" y="3182112"/>
+            <a:ext cx="2468880" cy="594360"/>
           </a:xfrm>
           <a:prstGeom prst="rect">
             <a:avLst/>
@@ -15072,32 +15246,33 @@
           <a:p>
             <a:pPr algn="l"/>
             <a:r>
-              <a:rPr sz="900" b="0" i="0">
-                <a:solidFill>
-                  <a:srgbClr val="FF9900"/>
+              <a:rPr sz="1000" b="0" i="0">
+                <a:solidFill>
+                  <a:srgbClr val="E2E8F0"/>
                 </a:solidFill>
               </a:rPr>
-              <a:t>▶  Color-coded feature type badges</a:t>
-            </a:r>
-          </a:p>
-        </p:txBody>
-      </p:sp>
-      <p:sp>
-        <p:nvSpPr>
-          <p:cNvPr id="15" name="Rectangle 14"/>
-          <p:cNvSpPr/>
-          <p:nvPr/>
-        </p:nvSpPr>
-        <p:spPr>
-          <a:xfrm>
-            <a:off x="8549640" y="1335024"/>
-            <a:ext cx="2606040" cy="292608"/>
-          </a:xfrm>
-          <a:prstGeom prst="rect">
-            <a:avLst/>
-          </a:prstGeom>
-          <a:solidFill>
-            <a:srgbClr val="0D1A26"/>
+              <a:t>Result count
+always visible</a:t>
+            </a:r>
+          </a:p>
+        </p:txBody>
+      </p:sp>
+      <p:sp>
+        <p:nvSpPr>
+          <p:cNvPr id="19" name="Rectangle 18"/>
+          <p:cNvSpPr/>
+          <p:nvPr/>
+        </p:nvSpPr>
+        <p:spPr>
+          <a:xfrm>
+            <a:off x="8257032" y="3950208"/>
+            <a:ext cx="2596896" cy="749808"/>
+          </a:xfrm>
+          <a:prstGeom prst="rect">
+            <a:avLst/>
+          </a:prstGeom>
+          <a:solidFill>
+            <a:srgbClr val="1A2A3E"/>
           </a:solidFill>
           <a:ln>
             <a:noFill/>
@@ -15127,14 +15302,57 @@
       </p:sp>
       <p:sp>
         <p:nvSpPr>
-          <p:cNvPr id="16" name="TextBox 15"/>
+          <p:cNvPr id="20" name="Rectangle 19"/>
+          <p:cNvSpPr/>
+          <p:nvPr/>
+        </p:nvSpPr>
+        <p:spPr>
+          <a:xfrm>
+            <a:off x="8257032" y="3950208"/>
+            <a:ext cx="36576" cy="749808"/>
+          </a:xfrm>
+          <a:prstGeom prst="rect">
+            <a:avLst/>
+          </a:prstGeom>
+          <a:solidFill>
+            <a:srgbClr val="FF9900"/>
+          </a:solidFill>
+          <a:ln>
+            <a:noFill/>
+          </a:ln>
+        </p:spPr>
+        <p:style>
+          <a:lnRef idx="1">
+            <a:schemeClr val="accent1"/>
+          </a:lnRef>
+          <a:fillRef idx="3">
+            <a:schemeClr val="accent1"/>
+          </a:fillRef>
+          <a:effectRef idx="2">
+            <a:schemeClr val="accent1"/>
+          </a:effectRef>
+          <a:fontRef idx="minor">
+            <a:schemeClr val="lt1"/>
+          </a:fontRef>
+        </p:style>
+        <p:txBody>
+          <a:bodyPr rtlCol="0" anchor="ctr"/>
+          <a:lstStyle/>
+          <a:p>
+            <a:pPr algn="ctr"/>
+          </a:p>
+        </p:txBody>
+      </p:sp>
+      <p:sp>
+        <p:nvSpPr>
+          <p:cNvPr id="21" name="TextBox 20"/>
           <p:cNvSpPr txBox="1"/>
           <p:nvPr/>
         </p:nvSpPr>
         <p:spPr>
           <a:xfrm>
-            <a:off x="8622792" y="1380744"/>
-            <a:ext cx="2487168" cy="219456"/>
+            <a:off x="8348472" y="4041648"/>
+            <a:ext cx="2468880" cy="594360"/>
           </a:xfrm>
           <a:prstGeom prst="rect">
             <a:avLst/>
@@ -15149,32 +15367,33 @@
           <a:p>
             <a:pPr algn="l"/>
             <a:r>
-              <a:rPr sz="900" b="0" i="0">
-                <a:solidFill>
-                  <a:srgbClr val="FF9900"/>
+              <a:rPr sz="1000" b="0" i="0">
+                <a:solidFill>
+                  <a:srgbClr val="E2E8F0"/>
                 </a:solidFill>
               </a:rPr>
-              <a:t>▶  AI key points — expand on hover</a:t>
-            </a:r>
-          </a:p>
-        </p:txBody>
-      </p:sp>
-      <p:sp>
-        <p:nvSpPr>
-          <p:cNvPr id="17" name="Rectangle 16"/>
-          <p:cNvSpPr/>
-          <p:nvPr/>
-        </p:nvSpPr>
-        <p:spPr>
-          <a:xfrm>
-            <a:off x="8549640" y="1737360"/>
-            <a:ext cx="2606040" cy="292608"/>
-          </a:xfrm>
-          <a:prstGeom prst="rect">
-            <a:avLst/>
-          </a:prstGeom>
-          <a:solidFill>
-            <a:srgbClr val="0D1A26"/>
+              <a:t>Color-coded
+feature type badges</a:t>
+            </a:r>
+          </a:p>
+        </p:txBody>
+      </p:sp>
+      <p:sp>
+        <p:nvSpPr>
+          <p:cNvPr id="22" name="Rectangle 21"/>
+          <p:cNvSpPr/>
+          <p:nvPr/>
+        </p:nvSpPr>
+        <p:spPr>
+          <a:xfrm>
+            <a:off x="8257032" y="4809744"/>
+            <a:ext cx="2596896" cy="749808"/>
+          </a:xfrm>
+          <a:prstGeom prst="rect">
+            <a:avLst/>
+          </a:prstGeom>
+          <a:solidFill>
+            <a:srgbClr val="1A2A3E"/>
           </a:solidFill>
           <a:ln>
             <a:noFill/>
@@ -15204,14 +15423,57 @@
       </p:sp>
       <p:sp>
         <p:nvSpPr>
-          <p:cNvPr id="18" name="TextBox 17"/>
+          <p:cNvPr id="23" name="Rectangle 22"/>
+          <p:cNvSpPr/>
+          <p:nvPr/>
+        </p:nvSpPr>
+        <p:spPr>
+          <a:xfrm>
+            <a:off x="8257032" y="4809744"/>
+            <a:ext cx="36576" cy="749808"/>
+          </a:xfrm>
+          <a:prstGeom prst="rect">
+            <a:avLst/>
+          </a:prstGeom>
+          <a:solidFill>
+            <a:srgbClr val="FF9900"/>
+          </a:solidFill>
+          <a:ln>
+            <a:noFill/>
+          </a:ln>
+        </p:spPr>
+        <p:style>
+          <a:lnRef idx="1">
+            <a:schemeClr val="accent1"/>
+          </a:lnRef>
+          <a:fillRef idx="3">
+            <a:schemeClr val="accent1"/>
+          </a:fillRef>
+          <a:effectRef idx="2">
+            <a:schemeClr val="accent1"/>
+          </a:effectRef>
+          <a:fontRef idx="minor">
+            <a:schemeClr val="lt1"/>
+          </a:fontRef>
+        </p:style>
+        <p:txBody>
+          <a:bodyPr rtlCol="0" anchor="ctr"/>
+          <a:lstStyle/>
+          <a:p>
+            <a:pPr algn="ctr"/>
+          </a:p>
+        </p:txBody>
+      </p:sp>
+      <p:sp>
+        <p:nvSpPr>
+          <p:cNvPr id="24" name="TextBox 23"/>
           <p:cNvSpPr txBox="1"/>
           <p:nvPr/>
         </p:nvSpPr>
         <p:spPr>
           <a:xfrm>
-            <a:off x="8622792" y="1783080"/>
-            <a:ext cx="2487168" cy="219456"/>
+            <a:off x="8348472" y="4901184"/>
+            <a:ext cx="2468880" cy="594360"/>
           </a:xfrm>
           <a:prstGeom prst="rect">
             <a:avLst/>
@@ -15226,12 +15488,134 @@
           <a:p>
             <a:pPr algn="l"/>
             <a:r>
-              <a:rPr sz="900" b="0" i="0">
-                <a:solidFill>
-                  <a:srgbClr val="FF9900"/>
+              <a:rPr sz="1000" b="0" i="0">
+                <a:solidFill>
+                  <a:srgbClr val="E2E8F0"/>
                 </a:solidFill>
               </a:rPr>
-              <a:t>▶  Direct AWS announcement links</a:t>
+              <a:t>AI key points
+expandable per card</a:t>
+            </a:r>
+          </a:p>
+        </p:txBody>
+      </p:sp>
+      <p:sp>
+        <p:nvSpPr>
+          <p:cNvPr id="25" name="Rectangle 24"/>
+          <p:cNvSpPr/>
+          <p:nvPr/>
+        </p:nvSpPr>
+        <p:spPr>
+          <a:xfrm>
+            <a:off x="8257032" y="5669279"/>
+            <a:ext cx="2596896" cy="749808"/>
+          </a:xfrm>
+          <a:prstGeom prst="rect">
+            <a:avLst/>
+          </a:prstGeom>
+          <a:solidFill>
+            <a:srgbClr val="1A2A3E"/>
+          </a:solidFill>
+          <a:ln>
+            <a:noFill/>
+          </a:ln>
+        </p:spPr>
+        <p:style>
+          <a:lnRef idx="1">
+            <a:schemeClr val="accent1"/>
+          </a:lnRef>
+          <a:fillRef idx="3">
+            <a:schemeClr val="accent1"/>
+          </a:fillRef>
+          <a:effectRef idx="2">
+            <a:schemeClr val="accent1"/>
+          </a:effectRef>
+          <a:fontRef idx="minor">
+            <a:schemeClr val="lt1"/>
+          </a:fontRef>
+        </p:style>
+        <p:txBody>
+          <a:bodyPr rtlCol="0" anchor="ctr"/>
+          <a:lstStyle/>
+          <a:p>
+            <a:pPr algn="ctr"/>
+          </a:p>
+        </p:txBody>
+      </p:sp>
+      <p:sp>
+        <p:nvSpPr>
+          <p:cNvPr id="26" name="Rectangle 25"/>
+          <p:cNvSpPr/>
+          <p:nvPr/>
+        </p:nvSpPr>
+        <p:spPr>
+          <a:xfrm>
+            <a:off x="8257032" y="5669279"/>
+            <a:ext cx="36576" cy="749808"/>
+          </a:xfrm>
+          <a:prstGeom prst="rect">
+            <a:avLst/>
+          </a:prstGeom>
+          <a:solidFill>
+            <a:srgbClr val="FF9900"/>
+          </a:solidFill>
+          <a:ln>
+            <a:noFill/>
+          </a:ln>
+        </p:spPr>
+        <p:style>
+          <a:lnRef idx="1">
+            <a:schemeClr val="accent1"/>
+          </a:lnRef>
+          <a:fillRef idx="3">
+            <a:schemeClr val="accent1"/>
+          </a:fillRef>
+          <a:effectRef idx="2">
+            <a:schemeClr val="accent1"/>
+          </a:effectRef>
+          <a:fontRef idx="minor">
+            <a:schemeClr val="lt1"/>
+          </a:fontRef>
+        </p:style>
+        <p:txBody>
+          <a:bodyPr rtlCol="0" anchor="ctr"/>
+          <a:lstStyle/>
+          <a:p>
+            <a:pPr algn="ctr"/>
+          </a:p>
+        </p:txBody>
+      </p:sp>
+      <p:sp>
+        <p:nvSpPr>
+          <p:cNvPr id="27" name="TextBox 26"/>
+          <p:cNvSpPr txBox="1"/>
+          <p:nvPr/>
+        </p:nvSpPr>
+        <p:spPr>
+          <a:xfrm>
+            <a:off x="8348472" y="5760719"/>
+            <a:ext cx="2468880" cy="594360"/>
+          </a:xfrm>
+          <a:prstGeom prst="rect">
+            <a:avLst/>
+          </a:prstGeom>
+          <a:noFill/>
+        </p:spPr>
+        <p:txBody>
+          <a:bodyPr wrap="square">
+            <a:spAutoFit/>
+          </a:bodyPr>
+          <a:lstStyle/>
+          <a:p>
+            <a:pPr algn="l"/>
+            <a:r>
+              <a:rPr sz="1000" b="0" i="0">
+                <a:solidFill>
+                  <a:srgbClr val="E2E8F0"/>
+                </a:solidFill>
+              </a:rPr>
+              <a:t>Direct link to
+AWS announcement</a:t>
             </a:r>
           </a:p>
         </p:txBody>
@@ -15382,8 +15766,8 @@
         </p:nvSpPr>
         <p:spPr>
           <a:xfrm>
-            <a:off x="502920" y="384048"/>
-            <a:ext cx="8686800" cy="457200"/>
+            <a:off x="320040" y="274320"/>
+            <a:ext cx="8686800" cy="475488"/>
           </a:xfrm>
           <a:prstGeom prst="rect">
             <a:avLst/>
@@ -15398,7 +15782,7 @@
           <a:p>
             <a:pPr algn="l"/>
             <a:r>
-              <a:rPr sz="2200" b="1" i="0">
+              <a:rPr sz="2000" b="1" i="0">
                 <a:solidFill>
                   <a:srgbClr val="FFFFFF"/>
                 </a:solidFill>
@@ -15424,8 +15808,8 @@
         </p:blipFill>
         <p:spPr>
           <a:xfrm>
-            <a:off x="320040" y="896112"/>
-            <a:ext cx="11539728" cy="5486400"/>
+            <a:off x="320040" y="841248"/>
+            <a:ext cx="7662672" cy="5907024"/>
           </a:xfrm>
           <a:prstGeom prst="rect">
             <a:avLst/>
@@ -15440,14 +15824,14 @@
         </p:nvSpPr>
         <p:spPr>
           <a:xfrm>
-            <a:off x="347472" y="932688"/>
-            <a:ext cx="2606040" cy="292608"/>
-          </a:xfrm>
-          <a:prstGeom prst="rect">
-            <a:avLst/>
-          </a:prstGeom>
-          <a:solidFill>
-            <a:srgbClr val="0D1A26"/>
+            <a:off x="8092440" y="841248"/>
+            <a:ext cx="2852928" cy="5907024"/>
+          </a:xfrm>
+          <a:prstGeom prst="rect">
+            <a:avLst/>
+          </a:prstGeom>
+          <a:solidFill>
+            <a:srgbClr val="0D1A2E"/>
           </a:solidFill>
           <a:ln>
             <a:noFill/>
@@ -15477,14 +15861,57 @@
       </p:sp>
       <p:sp>
         <p:nvSpPr>
-          <p:cNvPr id="8" name="TextBox 7"/>
+          <p:cNvPr id="8" name="Rectangle 7"/>
+          <p:cNvSpPr/>
+          <p:nvPr/>
+        </p:nvSpPr>
+        <p:spPr>
+          <a:xfrm>
+            <a:off x="8092440" y="841248"/>
+            <a:ext cx="54864" cy="5907024"/>
+          </a:xfrm>
+          <a:prstGeom prst="rect">
+            <a:avLst/>
+          </a:prstGeom>
+          <a:solidFill>
+            <a:srgbClr val="FF9900"/>
+          </a:solidFill>
+          <a:ln>
+            <a:noFill/>
+          </a:ln>
+        </p:spPr>
+        <p:style>
+          <a:lnRef idx="1">
+            <a:schemeClr val="accent1"/>
+          </a:lnRef>
+          <a:fillRef idx="3">
+            <a:schemeClr val="accent1"/>
+          </a:fillRef>
+          <a:effectRef idx="2">
+            <a:schemeClr val="accent1"/>
+          </a:effectRef>
+          <a:fontRef idx="minor">
+            <a:schemeClr val="lt1"/>
+          </a:fontRef>
+        </p:style>
+        <p:txBody>
+          <a:bodyPr rtlCol="0" anchor="ctr"/>
+          <a:lstStyle/>
+          <a:p>
+            <a:pPr algn="ctr"/>
+          </a:p>
+        </p:txBody>
+      </p:sp>
+      <p:sp>
+        <p:nvSpPr>
+          <p:cNvPr id="9" name="TextBox 8"/>
           <p:cNvSpPr txBox="1"/>
           <p:nvPr/>
         </p:nvSpPr>
         <p:spPr>
           <a:xfrm>
-            <a:off x="420624" y="978408"/>
-            <a:ext cx="2487168" cy="219456"/>
+            <a:off x="8257032" y="1005840"/>
+            <a:ext cx="2596896" cy="256032"/>
           </a:xfrm>
           <a:prstGeom prst="rect">
             <a:avLst/>
@@ -15499,32 +15926,32 @@
           <a:p>
             <a:pPr algn="l"/>
             <a:r>
-              <a:rPr sz="900" b="0" i="0">
+              <a:rPr sz="800" b="1" i="0">
                 <a:solidFill>
                   <a:srgbClr val="FF9900"/>
                 </a:solidFill>
               </a:rPr>
-              <a:t>▶  Badges: date · service · domain · type</a:t>
-            </a:r>
-          </a:p>
-        </p:txBody>
-      </p:sp>
-      <p:sp>
-        <p:nvSpPr>
-          <p:cNvPr id="9" name="Rectangle 8"/>
-          <p:cNvSpPr/>
-          <p:nvPr/>
-        </p:nvSpPr>
-        <p:spPr>
-          <a:xfrm>
-            <a:off x="347472" y="1335024"/>
-            <a:ext cx="2606040" cy="292608"/>
-          </a:xfrm>
-          <a:prstGeom prst="rect">
-            <a:avLst/>
-          </a:prstGeom>
-          <a:solidFill>
-            <a:srgbClr val="0D1A26"/>
+              <a:t>KEY HIGHLIGHTS</a:t>
+            </a:r>
+          </a:p>
+        </p:txBody>
+      </p:sp>
+      <p:sp>
+        <p:nvSpPr>
+          <p:cNvPr id="10" name="Rectangle 9"/>
+          <p:cNvSpPr/>
+          <p:nvPr/>
+        </p:nvSpPr>
+        <p:spPr>
+          <a:xfrm>
+            <a:off x="8257032" y="1371600"/>
+            <a:ext cx="2596896" cy="749808"/>
+          </a:xfrm>
+          <a:prstGeom prst="rect">
+            <a:avLst/>
+          </a:prstGeom>
+          <a:solidFill>
+            <a:srgbClr val="1A2A3E"/>
           </a:solidFill>
           <a:ln>
             <a:noFill/>
@@ -15554,14 +15981,57 @@
       </p:sp>
       <p:sp>
         <p:nvSpPr>
-          <p:cNvPr id="10" name="TextBox 9"/>
+          <p:cNvPr id="11" name="Rectangle 10"/>
+          <p:cNvSpPr/>
+          <p:nvPr/>
+        </p:nvSpPr>
+        <p:spPr>
+          <a:xfrm>
+            <a:off x="8257032" y="1371600"/>
+            <a:ext cx="36576" cy="749808"/>
+          </a:xfrm>
+          <a:prstGeom prst="rect">
+            <a:avLst/>
+          </a:prstGeom>
+          <a:solidFill>
+            <a:srgbClr val="FF9900"/>
+          </a:solidFill>
+          <a:ln>
+            <a:noFill/>
+          </a:ln>
+        </p:spPr>
+        <p:style>
+          <a:lnRef idx="1">
+            <a:schemeClr val="accent1"/>
+          </a:lnRef>
+          <a:fillRef idx="3">
+            <a:schemeClr val="accent1"/>
+          </a:fillRef>
+          <a:effectRef idx="2">
+            <a:schemeClr val="accent1"/>
+          </a:effectRef>
+          <a:fontRef idx="minor">
+            <a:schemeClr val="lt1"/>
+          </a:fontRef>
+        </p:style>
+        <p:txBody>
+          <a:bodyPr rtlCol="0" anchor="ctr"/>
+          <a:lstStyle/>
+          <a:p>
+            <a:pPr algn="ctr"/>
+          </a:p>
+        </p:txBody>
+      </p:sp>
+      <p:sp>
+        <p:nvSpPr>
+          <p:cNvPr id="12" name="TextBox 11"/>
           <p:cNvSpPr txBox="1"/>
           <p:nvPr/>
         </p:nvSpPr>
         <p:spPr>
           <a:xfrm>
-            <a:off x="420624" y="1380744"/>
-            <a:ext cx="2487168" cy="219456"/>
+            <a:off x="8348472" y="1463040"/>
+            <a:ext cx="2468880" cy="594360"/>
           </a:xfrm>
           <a:prstGeom prst="rect">
             <a:avLst/>
@@ -15576,32 +16046,33 @@
           <a:p>
             <a:pPr algn="l"/>
             <a:r>
-              <a:rPr sz="900" b="0" i="0">
-                <a:solidFill>
-                  <a:srgbClr val="FF9900"/>
+              <a:rPr sz="1000" b="0" i="0">
+                <a:solidFill>
+                  <a:srgbClr val="E2E8F0"/>
                 </a:solidFill>
               </a:rPr>
-              <a:t>▶  3–5 sentence AI summary, engineer-focused</a:t>
-            </a:r>
-          </a:p>
-        </p:txBody>
-      </p:sp>
-      <p:sp>
-        <p:nvSpPr>
-          <p:cNvPr id="11" name="Rectangle 10"/>
-          <p:cNvSpPr/>
-          <p:nvPr/>
-        </p:nvSpPr>
-        <p:spPr>
-          <a:xfrm>
-            <a:off x="347472" y="1737360"/>
-            <a:ext cx="2606040" cy="292608"/>
-          </a:xfrm>
-          <a:prstGeom prst="rect">
-            <a:avLst/>
-          </a:prstGeom>
-          <a:solidFill>
-            <a:srgbClr val="0D1A26"/>
+              <a:t>Badges: date,
+service, domain, type</a:t>
+            </a:r>
+          </a:p>
+        </p:txBody>
+      </p:sp>
+      <p:sp>
+        <p:nvSpPr>
+          <p:cNvPr id="13" name="Rectangle 12"/>
+          <p:cNvSpPr/>
+          <p:nvPr/>
+        </p:nvSpPr>
+        <p:spPr>
+          <a:xfrm>
+            <a:off x="8257032" y="2231136"/>
+            <a:ext cx="2596896" cy="749808"/>
+          </a:xfrm>
+          <a:prstGeom prst="rect">
+            <a:avLst/>
+          </a:prstGeom>
+          <a:solidFill>
+            <a:srgbClr val="1A2A3E"/>
           </a:solidFill>
           <a:ln>
             <a:noFill/>
@@ -15631,14 +16102,57 @@
       </p:sp>
       <p:sp>
         <p:nvSpPr>
-          <p:cNvPr id="12" name="TextBox 11"/>
+          <p:cNvPr id="14" name="Rectangle 13"/>
+          <p:cNvSpPr/>
+          <p:nvPr/>
+        </p:nvSpPr>
+        <p:spPr>
+          <a:xfrm>
+            <a:off x="8257032" y="2231136"/>
+            <a:ext cx="36576" cy="749808"/>
+          </a:xfrm>
+          <a:prstGeom prst="rect">
+            <a:avLst/>
+          </a:prstGeom>
+          <a:solidFill>
+            <a:srgbClr val="FF9900"/>
+          </a:solidFill>
+          <a:ln>
+            <a:noFill/>
+          </a:ln>
+        </p:spPr>
+        <p:style>
+          <a:lnRef idx="1">
+            <a:schemeClr val="accent1"/>
+          </a:lnRef>
+          <a:fillRef idx="3">
+            <a:schemeClr val="accent1"/>
+          </a:fillRef>
+          <a:effectRef idx="2">
+            <a:schemeClr val="accent1"/>
+          </a:effectRef>
+          <a:fontRef idx="minor">
+            <a:schemeClr val="lt1"/>
+          </a:fontRef>
+        </p:style>
+        <p:txBody>
+          <a:bodyPr rtlCol="0" anchor="ctr"/>
+          <a:lstStyle/>
+          <a:p>
+            <a:pPr algn="ctr"/>
+          </a:p>
+        </p:txBody>
+      </p:sp>
+      <p:sp>
+        <p:nvSpPr>
+          <p:cNvPr id="15" name="TextBox 14"/>
           <p:cNvSpPr txBox="1"/>
           <p:nvPr/>
         </p:nvSpPr>
         <p:spPr>
           <a:xfrm>
-            <a:off x="420624" y="1783080"/>
-            <a:ext cx="2487168" cy="219456"/>
+            <a:off x="8348472" y="2322576"/>
+            <a:ext cx="2468880" cy="594360"/>
           </a:xfrm>
           <a:prstGeom prst="rect">
             <a:avLst/>
@@ -15653,32 +16167,33 @@
           <a:p>
             <a:pPr algn="l"/>
             <a:r>
-              <a:rPr sz="900" b="0" i="0">
-                <a:solidFill>
-                  <a:srgbClr val="FF9900"/>
+              <a:rPr sz="1000" b="0" i="0">
+                <a:solidFill>
+                  <a:srgbClr val="E2E8F0"/>
                 </a:solidFill>
               </a:rPr>
-              <a:t>▶  Structured key points for rapid evaluation</a:t>
-            </a:r>
-          </a:p>
-        </p:txBody>
-      </p:sp>
-      <p:sp>
-        <p:nvSpPr>
-          <p:cNvPr id="13" name="Rectangle 12"/>
-          <p:cNvSpPr/>
-          <p:nvPr/>
-        </p:nvSpPr>
-        <p:spPr>
-          <a:xfrm>
-            <a:off x="8549640" y="932688"/>
-            <a:ext cx="2606040" cy="292608"/>
-          </a:xfrm>
-          <a:prstGeom prst="rect">
-            <a:avLst/>
-          </a:prstGeom>
-          <a:solidFill>
-            <a:srgbClr val="0D1A26"/>
+              <a:t>3–5 sentence AI
+summary, engineer-focused</a:t>
+            </a:r>
+          </a:p>
+        </p:txBody>
+      </p:sp>
+      <p:sp>
+        <p:nvSpPr>
+          <p:cNvPr id="16" name="Rectangle 15"/>
+          <p:cNvSpPr/>
+          <p:nvPr/>
+        </p:nvSpPr>
+        <p:spPr>
+          <a:xfrm>
+            <a:off x="8257032" y="3090672"/>
+            <a:ext cx="2596896" cy="749808"/>
+          </a:xfrm>
+          <a:prstGeom prst="rect">
+            <a:avLst/>
+          </a:prstGeom>
+          <a:solidFill>
+            <a:srgbClr val="1A2A3E"/>
           </a:solidFill>
           <a:ln>
             <a:noFill/>
@@ -15708,14 +16223,57 @@
       </p:sp>
       <p:sp>
         <p:nvSpPr>
-          <p:cNvPr id="14" name="TextBox 13"/>
+          <p:cNvPr id="17" name="Rectangle 16"/>
+          <p:cNvSpPr/>
+          <p:nvPr/>
+        </p:nvSpPr>
+        <p:spPr>
+          <a:xfrm>
+            <a:off x="8257032" y="3090672"/>
+            <a:ext cx="36576" cy="749808"/>
+          </a:xfrm>
+          <a:prstGeom prst="rect">
+            <a:avLst/>
+          </a:prstGeom>
+          <a:solidFill>
+            <a:srgbClr val="FF9900"/>
+          </a:solidFill>
+          <a:ln>
+            <a:noFill/>
+          </a:ln>
+        </p:spPr>
+        <p:style>
+          <a:lnRef idx="1">
+            <a:schemeClr val="accent1"/>
+          </a:lnRef>
+          <a:fillRef idx="3">
+            <a:schemeClr val="accent1"/>
+          </a:fillRef>
+          <a:effectRef idx="2">
+            <a:schemeClr val="accent1"/>
+          </a:effectRef>
+          <a:fontRef idx="minor">
+            <a:schemeClr val="lt1"/>
+          </a:fontRef>
+        </p:style>
+        <p:txBody>
+          <a:bodyPr rtlCol="0" anchor="ctr"/>
+          <a:lstStyle/>
+          <a:p>
+            <a:pPr algn="ctr"/>
+          </a:p>
+        </p:txBody>
+      </p:sp>
+      <p:sp>
+        <p:nvSpPr>
+          <p:cNvPr id="18" name="TextBox 17"/>
           <p:cNvSpPr txBox="1"/>
           <p:nvPr/>
         </p:nvSpPr>
         <p:spPr>
           <a:xfrm>
-            <a:off x="8622792" y="978408"/>
-            <a:ext cx="2487168" cy="219456"/>
+            <a:off x="8348472" y="3182112"/>
+            <a:ext cx="2468880" cy="594360"/>
           </a:xfrm>
           <a:prstGeom prst="rect">
             <a:avLst/>
@@ -15730,32 +16288,33 @@
           <a:p>
             <a:pPr algn="l"/>
             <a:r>
-              <a:rPr sz="900" b="0" i="0">
-                <a:solidFill>
-                  <a:srgbClr val="FF9900"/>
+              <a:rPr sz="1000" b="0" i="0">
+                <a:solidFill>
+                  <a:srgbClr val="E2E8F0"/>
                 </a:solidFill>
               </a:rPr>
-              <a:t>▶  Link to original AWS announcement</a:t>
-            </a:r>
-          </a:p>
-        </p:txBody>
-      </p:sp>
-      <p:sp>
-        <p:nvSpPr>
-          <p:cNvPr id="15" name="Rectangle 14"/>
-          <p:cNvSpPr/>
-          <p:nvPr/>
-        </p:nvSpPr>
-        <p:spPr>
-          <a:xfrm>
-            <a:off x="8549640" y="1335024"/>
-            <a:ext cx="2606040" cy="292608"/>
-          </a:xfrm>
-          <a:prstGeom prst="rect">
-            <a:avLst/>
-          </a:prstGeom>
-          <a:solidFill>
-            <a:srgbClr val="0D1A26"/>
+              <a:t>Structured key
+points for evaluation</a:t>
+            </a:r>
+          </a:p>
+        </p:txBody>
+      </p:sp>
+      <p:sp>
+        <p:nvSpPr>
+          <p:cNvPr id="19" name="Rectangle 18"/>
+          <p:cNvSpPr/>
+          <p:nvPr/>
+        </p:nvSpPr>
+        <p:spPr>
+          <a:xfrm>
+            <a:off x="8257032" y="3950208"/>
+            <a:ext cx="2596896" cy="749808"/>
+          </a:xfrm>
+          <a:prstGeom prst="rect">
+            <a:avLst/>
+          </a:prstGeom>
+          <a:solidFill>
+            <a:srgbClr val="1A2A3E"/>
           </a:solidFill>
           <a:ln>
             <a:noFill/>
@@ -15785,14 +16344,57 @@
       </p:sp>
       <p:sp>
         <p:nvSpPr>
-          <p:cNvPr id="16" name="TextBox 15"/>
+          <p:cNvPr id="20" name="Rectangle 19"/>
+          <p:cNvSpPr/>
+          <p:nvPr/>
+        </p:nvSpPr>
+        <p:spPr>
+          <a:xfrm>
+            <a:off x="8257032" y="3950208"/>
+            <a:ext cx="36576" cy="749808"/>
+          </a:xfrm>
+          <a:prstGeom prst="rect">
+            <a:avLst/>
+          </a:prstGeom>
+          <a:solidFill>
+            <a:srgbClr val="FF9900"/>
+          </a:solidFill>
+          <a:ln>
+            <a:noFill/>
+          </a:ln>
+        </p:spPr>
+        <p:style>
+          <a:lnRef idx="1">
+            <a:schemeClr val="accent1"/>
+          </a:lnRef>
+          <a:fillRef idx="3">
+            <a:schemeClr val="accent1"/>
+          </a:fillRef>
+          <a:effectRef idx="2">
+            <a:schemeClr val="accent1"/>
+          </a:effectRef>
+          <a:fontRef idx="minor">
+            <a:schemeClr val="lt1"/>
+          </a:fontRef>
+        </p:style>
+        <p:txBody>
+          <a:bodyPr rtlCol="0" anchor="ctr"/>
+          <a:lstStyle/>
+          <a:p>
+            <a:pPr algn="ctr"/>
+          </a:p>
+        </p:txBody>
+      </p:sp>
+      <p:sp>
+        <p:nvSpPr>
+          <p:cNvPr id="21" name="TextBox 20"/>
           <p:cNvSpPr txBox="1"/>
           <p:nvPr/>
         </p:nvSpPr>
         <p:spPr>
           <a:xfrm>
-            <a:off x="8622792" y="1380744"/>
-            <a:ext cx="2487168" cy="219456"/>
+            <a:off x="8348472" y="4041648"/>
+            <a:ext cx="2468880" cy="594360"/>
           </a:xfrm>
           <a:prstGeom prst="rect">
             <a:avLst/>
@@ -15807,32 +16409,33 @@
           <a:p>
             <a:pPr algn="l"/>
             <a:r>
-              <a:rPr sz="900" b="0" i="0">
-                <a:solidFill>
-                  <a:srgbClr val="FF9900"/>
+              <a:rPr sz="1000" b="0" i="0">
+                <a:solidFill>
+                  <a:srgbClr val="E2E8F0"/>
                 </a:solidFill>
               </a:rPr>
-              <a:t>▶  Back button preserves search state</a:t>
-            </a:r>
-          </a:p>
-        </p:txBody>
-      </p:sp>
-      <p:sp>
-        <p:nvSpPr>
-          <p:cNvPr id="17" name="Rectangle 16"/>
-          <p:cNvSpPr/>
-          <p:nvPr/>
-        </p:nvSpPr>
-        <p:spPr>
-          <a:xfrm>
-            <a:off x="8549640" y="1737360"/>
-            <a:ext cx="2606040" cy="292608"/>
-          </a:xfrm>
-          <a:prstGeom prst="rect">
-            <a:avLst/>
-          </a:prstGeom>
-          <a:solidFill>
-            <a:srgbClr val="0D1A26"/>
+              <a:t>One-click link to
+AWS announcement</a:t>
+            </a:r>
+          </a:p>
+        </p:txBody>
+      </p:sp>
+      <p:sp>
+        <p:nvSpPr>
+          <p:cNvPr id="22" name="Rectangle 21"/>
+          <p:cNvSpPr/>
+          <p:nvPr/>
+        </p:nvSpPr>
+        <p:spPr>
+          <a:xfrm>
+            <a:off x="8257032" y="4809744"/>
+            <a:ext cx="2596896" cy="749808"/>
+          </a:xfrm>
+          <a:prstGeom prst="rect">
+            <a:avLst/>
+          </a:prstGeom>
+          <a:solidFill>
+            <a:srgbClr val="1A2A3E"/>
           </a:solidFill>
           <a:ln>
             <a:noFill/>
@@ -15862,14 +16465,57 @@
       </p:sp>
       <p:sp>
         <p:nvSpPr>
-          <p:cNvPr id="18" name="TextBox 17"/>
+          <p:cNvPr id="23" name="Rectangle 22"/>
+          <p:cNvSpPr/>
+          <p:nvPr/>
+        </p:nvSpPr>
+        <p:spPr>
+          <a:xfrm>
+            <a:off x="8257032" y="4809744"/>
+            <a:ext cx="36576" cy="749808"/>
+          </a:xfrm>
+          <a:prstGeom prst="rect">
+            <a:avLst/>
+          </a:prstGeom>
+          <a:solidFill>
+            <a:srgbClr val="FF9900"/>
+          </a:solidFill>
+          <a:ln>
+            <a:noFill/>
+          </a:ln>
+        </p:spPr>
+        <p:style>
+          <a:lnRef idx="1">
+            <a:schemeClr val="accent1"/>
+          </a:lnRef>
+          <a:fillRef idx="3">
+            <a:schemeClr val="accent1"/>
+          </a:fillRef>
+          <a:effectRef idx="2">
+            <a:schemeClr val="accent1"/>
+          </a:effectRef>
+          <a:fontRef idx="minor">
+            <a:schemeClr val="lt1"/>
+          </a:fontRef>
+        </p:style>
+        <p:txBody>
+          <a:bodyPr rtlCol="0" anchor="ctr"/>
+          <a:lstStyle/>
+          <a:p>
+            <a:pPr algn="ctr"/>
+          </a:p>
+        </p:txBody>
+      </p:sp>
+      <p:sp>
+        <p:nvSpPr>
+          <p:cNvPr id="24" name="TextBox 23"/>
           <p:cNvSpPr txBox="1"/>
           <p:nvPr/>
         </p:nvSpPr>
         <p:spPr>
           <a:xfrm>
-            <a:off x="8622792" y="1783080"/>
-            <a:ext cx="2487168" cy="219456"/>
+            <a:off x="8348472" y="4901184"/>
+            <a:ext cx="2468880" cy="594360"/>
           </a:xfrm>
           <a:prstGeom prst="rect">
             <a:avLst/>
@@ -15884,12 +16530,134 @@
           <a:p>
             <a:pPr algn="l"/>
             <a:r>
-              <a:rPr sz="900" b="0" i="0">
-                <a:solidFill>
-                  <a:srgbClr val="FF9900"/>
+              <a:rPr sz="1000" b="0" i="0">
+                <a:solidFill>
+                  <a:srgbClr val="E2E8F0"/>
                 </a:solidFill>
               </a:rPr>
-              <a:t>▶  Summarized-at timestamp for audit</a:t>
+              <a:t>Back button
+preserves search state</a:t>
+            </a:r>
+          </a:p>
+        </p:txBody>
+      </p:sp>
+      <p:sp>
+        <p:nvSpPr>
+          <p:cNvPr id="25" name="Rectangle 24"/>
+          <p:cNvSpPr/>
+          <p:nvPr/>
+        </p:nvSpPr>
+        <p:spPr>
+          <a:xfrm>
+            <a:off x="8257032" y="5669279"/>
+            <a:ext cx="2596896" cy="749808"/>
+          </a:xfrm>
+          <a:prstGeom prst="rect">
+            <a:avLst/>
+          </a:prstGeom>
+          <a:solidFill>
+            <a:srgbClr val="1A2A3E"/>
+          </a:solidFill>
+          <a:ln>
+            <a:noFill/>
+          </a:ln>
+        </p:spPr>
+        <p:style>
+          <a:lnRef idx="1">
+            <a:schemeClr val="accent1"/>
+          </a:lnRef>
+          <a:fillRef idx="3">
+            <a:schemeClr val="accent1"/>
+          </a:fillRef>
+          <a:effectRef idx="2">
+            <a:schemeClr val="accent1"/>
+          </a:effectRef>
+          <a:fontRef idx="minor">
+            <a:schemeClr val="lt1"/>
+          </a:fontRef>
+        </p:style>
+        <p:txBody>
+          <a:bodyPr rtlCol="0" anchor="ctr"/>
+          <a:lstStyle/>
+          <a:p>
+            <a:pPr algn="ctr"/>
+          </a:p>
+        </p:txBody>
+      </p:sp>
+      <p:sp>
+        <p:nvSpPr>
+          <p:cNvPr id="26" name="Rectangle 25"/>
+          <p:cNvSpPr/>
+          <p:nvPr/>
+        </p:nvSpPr>
+        <p:spPr>
+          <a:xfrm>
+            <a:off x="8257032" y="5669279"/>
+            <a:ext cx="36576" cy="749808"/>
+          </a:xfrm>
+          <a:prstGeom prst="rect">
+            <a:avLst/>
+          </a:prstGeom>
+          <a:solidFill>
+            <a:srgbClr val="FF9900"/>
+          </a:solidFill>
+          <a:ln>
+            <a:noFill/>
+          </a:ln>
+        </p:spPr>
+        <p:style>
+          <a:lnRef idx="1">
+            <a:schemeClr val="accent1"/>
+          </a:lnRef>
+          <a:fillRef idx="3">
+            <a:schemeClr val="accent1"/>
+          </a:fillRef>
+          <a:effectRef idx="2">
+            <a:schemeClr val="accent1"/>
+          </a:effectRef>
+          <a:fontRef idx="minor">
+            <a:schemeClr val="lt1"/>
+          </a:fontRef>
+        </p:style>
+        <p:txBody>
+          <a:bodyPr rtlCol="0" anchor="ctr"/>
+          <a:lstStyle/>
+          <a:p>
+            <a:pPr algn="ctr"/>
+          </a:p>
+        </p:txBody>
+      </p:sp>
+      <p:sp>
+        <p:nvSpPr>
+          <p:cNvPr id="27" name="TextBox 26"/>
+          <p:cNvSpPr txBox="1"/>
+          <p:nvPr/>
+        </p:nvSpPr>
+        <p:spPr>
+          <a:xfrm>
+            <a:off x="8348472" y="5760719"/>
+            <a:ext cx="2468880" cy="594360"/>
+          </a:xfrm>
+          <a:prstGeom prst="rect">
+            <a:avLst/>
+          </a:prstGeom>
+          <a:noFill/>
+        </p:spPr>
+        <p:txBody>
+          <a:bodyPr wrap="square">
+            <a:spAutoFit/>
+          </a:bodyPr>
+          <a:lstStyle/>
+          <a:p>
+            <a:pPr algn="l"/>
+            <a:r>
+              <a:rPr sz="1000" b="0" i="0">
+                <a:solidFill>
+                  <a:srgbClr val="E2E8F0"/>
+                </a:solidFill>
+              </a:rPr>
+              <a:t>Summarized-at
+timestamp for audit</a:t>
             </a:r>
           </a:p>
         </p:txBody>
@@ -16040,8 +16808,8 @@
         </p:nvSpPr>
         <p:spPr>
           <a:xfrm>
-            <a:off x="502920" y="384048"/>
-            <a:ext cx="10058400" cy="457200"/>
+            <a:off x="320040" y="274320"/>
+            <a:ext cx="8686800" cy="475488"/>
           </a:xfrm>
           <a:prstGeom prst="rect">
             <a:avLst/>
@@ -16056,7 +16824,7 @@
           <a:p>
             <a:pPr algn="l"/>
             <a:r>
-              <a:rPr sz="2200" b="1" i="0">
+              <a:rPr sz="2000" b="1" i="0">
                 <a:solidFill>
                   <a:srgbClr val="FFFFFF"/>
                 </a:solidFill>
@@ -16082,8 +16850,8 @@
         </p:blipFill>
         <p:spPr>
           <a:xfrm>
-            <a:off x="320040" y="896112"/>
-            <a:ext cx="11539728" cy="5486400"/>
+            <a:off x="320040" y="841248"/>
+            <a:ext cx="7662672" cy="5907024"/>
           </a:xfrm>
           <a:prstGeom prst="rect">
             <a:avLst/>
@@ -16098,14 +16866,14 @@
         </p:nvSpPr>
         <p:spPr>
           <a:xfrm>
-            <a:off x="347472" y="932688"/>
-            <a:ext cx="2606040" cy="292608"/>
-          </a:xfrm>
-          <a:prstGeom prst="rect">
-            <a:avLst/>
-          </a:prstGeom>
-          <a:solidFill>
-            <a:srgbClr val="0D1A26"/>
+            <a:off x="8092440" y="841248"/>
+            <a:ext cx="2852928" cy="5907024"/>
+          </a:xfrm>
+          <a:prstGeom prst="rect">
+            <a:avLst/>
+          </a:prstGeom>
+          <a:solidFill>
+            <a:srgbClr val="0D1A2E"/>
           </a:solidFill>
           <a:ln>
             <a:noFill/>
@@ -16135,14 +16903,57 @@
       </p:sp>
       <p:sp>
         <p:nvSpPr>
-          <p:cNvPr id="8" name="TextBox 7"/>
+          <p:cNvPr id="8" name="Rectangle 7"/>
+          <p:cNvSpPr/>
+          <p:nvPr/>
+        </p:nvSpPr>
+        <p:spPr>
+          <a:xfrm>
+            <a:off x="8092440" y="841248"/>
+            <a:ext cx="54864" cy="5907024"/>
+          </a:xfrm>
+          <a:prstGeom prst="rect">
+            <a:avLst/>
+          </a:prstGeom>
+          <a:solidFill>
+            <a:srgbClr val="FF9900"/>
+          </a:solidFill>
+          <a:ln>
+            <a:noFill/>
+          </a:ln>
+        </p:spPr>
+        <p:style>
+          <a:lnRef idx="1">
+            <a:schemeClr val="accent1"/>
+          </a:lnRef>
+          <a:fillRef idx="3">
+            <a:schemeClr val="accent1"/>
+          </a:fillRef>
+          <a:effectRef idx="2">
+            <a:schemeClr val="accent1"/>
+          </a:effectRef>
+          <a:fontRef idx="minor">
+            <a:schemeClr val="lt1"/>
+          </a:fontRef>
+        </p:style>
+        <p:txBody>
+          <a:bodyPr rtlCol="0" anchor="ctr"/>
+          <a:lstStyle/>
+          <a:p>
+            <a:pPr algn="ctr"/>
+          </a:p>
+        </p:txBody>
+      </p:sp>
+      <p:sp>
+        <p:nvSpPr>
+          <p:cNvPr id="9" name="TextBox 8"/>
           <p:cNvSpPr txBox="1"/>
           <p:nvPr/>
         </p:nvSpPr>
         <p:spPr>
           <a:xfrm>
-            <a:off x="420624" y="978408"/>
-            <a:ext cx="2487168" cy="219456"/>
+            <a:off x="8257032" y="1005840"/>
+            <a:ext cx="2596896" cy="256032"/>
           </a:xfrm>
           <a:prstGeom prst="rect">
             <a:avLst/>
@@ -16157,32 +16968,32 @@
           <a:p>
             <a:pPr algn="l"/>
             <a:r>
-              <a:rPr sz="900" b="0" i="0">
+              <a:rPr sz="800" b="1" i="0">
                 <a:solidFill>
                   <a:srgbClr val="FF9900"/>
                 </a:solidFill>
               </a:rPr>
-              <a:t>▶  Keyword highlights matching records</a:t>
-            </a:r>
-          </a:p>
-        </p:txBody>
-      </p:sp>
-      <p:sp>
-        <p:nvSpPr>
-          <p:cNvPr id="9" name="Rectangle 8"/>
-          <p:cNvSpPr/>
-          <p:nvPr/>
-        </p:nvSpPr>
-        <p:spPr>
-          <a:xfrm>
-            <a:off x="347472" y="1335024"/>
-            <a:ext cx="2606040" cy="292608"/>
-          </a:xfrm>
-          <a:prstGeom prst="rect">
-            <a:avLst/>
-          </a:prstGeom>
-          <a:solidFill>
-            <a:srgbClr val="0D1A26"/>
+              <a:t>KEY HIGHLIGHTS</a:t>
+            </a:r>
+          </a:p>
+        </p:txBody>
+      </p:sp>
+      <p:sp>
+        <p:nvSpPr>
+          <p:cNvPr id="10" name="Rectangle 9"/>
+          <p:cNvSpPr/>
+          <p:nvPr/>
+        </p:nvSpPr>
+        <p:spPr>
+          <a:xfrm>
+            <a:off x="8257032" y="1371600"/>
+            <a:ext cx="2596896" cy="749808"/>
+          </a:xfrm>
+          <a:prstGeom prst="rect">
+            <a:avLst/>
+          </a:prstGeom>
+          <a:solidFill>
+            <a:srgbClr val="1A2A3E"/>
           </a:solidFill>
           <a:ln>
             <a:noFill/>
@@ -16212,14 +17023,57 @@
       </p:sp>
       <p:sp>
         <p:nvSpPr>
-          <p:cNvPr id="10" name="TextBox 9"/>
+          <p:cNvPr id="11" name="Rectangle 10"/>
+          <p:cNvSpPr/>
+          <p:nvPr/>
+        </p:nvSpPr>
+        <p:spPr>
+          <a:xfrm>
+            <a:off x="8257032" y="1371600"/>
+            <a:ext cx="36576" cy="749808"/>
+          </a:xfrm>
+          <a:prstGeom prst="rect">
+            <a:avLst/>
+          </a:prstGeom>
+          <a:solidFill>
+            <a:srgbClr val="FF9900"/>
+          </a:solidFill>
+          <a:ln>
+            <a:noFill/>
+          </a:ln>
+        </p:spPr>
+        <p:style>
+          <a:lnRef idx="1">
+            <a:schemeClr val="accent1"/>
+          </a:lnRef>
+          <a:fillRef idx="3">
+            <a:schemeClr val="accent1"/>
+          </a:fillRef>
+          <a:effectRef idx="2">
+            <a:schemeClr val="accent1"/>
+          </a:effectRef>
+          <a:fontRef idx="minor">
+            <a:schemeClr val="lt1"/>
+          </a:fontRef>
+        </p:style>
+        <p:txBody>
+          <a:bodyPr rtlCol="0" anchor="ctr"/>
+          <a:lstStyle/>
+          <a:p>
+            <a:pPr algn="ctr"/>
+          </a:p>
+        </p:txBody>
+      </p:sp>
+      <p:sp>
+        <p:nvSpPr>
+          <p:cNvPr id="12" name="TextBox 11"/>
           <p:cNvSpPr txBox="1"/>
           <p:nvPr/>
         </p:nvSpPr>
         <p:spPr>
           <a:xfrm>
-            <a:off x="420624" y="1380744"/>
-            <a:ext cx="2487168" cy="219456"/>
+            <a:off x="8348472" y="1463040"/>
+            <a:ext cx="2468880" cy="594360"/>
           </a:xfrm>
           <a:prstGeom prst="rect">
             <a:avLst/>
@@ -16234,32 +17088,33 @@
           <a:p>
             <a:pPr algn="l"/>
             <a:r>
-              <a:rPr sz="900" b="0" i="0">
-                <a:solidFill>
-                  <a:srgbClr val="FF9900"/>
+              <a:rPr sz="1000" b="0" i="0">
+                <a:solidFill>
+                  <a:srgbClr val="E2E8F0"/>
                 </a:solidFill>
               </a:rPr>
-              <a:t>▶  Active filter pills shown in header</a:t>
-            </a:r>
-          </a:p>
-        </p:txBody>
-      </p:sp>
-      <p:sp>
-        <p:nvSpPr>
-          <p:cNvPr id="11" name="Rectangle 10"/>
-          <p:cNvSpPr/>
-          <p:nvPr/>
-        </p:nvSpPr>
-        <p:spPr>
-          <a:xfrm>
-            <a:off x="347472" y="1737360"/>
-            <a:ext cx="2606040" cy="292608"/>
-          </a:xfrm>
-          <a:prstGeom prst="rect">
-            <a:avLst/>
-          </a:prstGeom>
-          <a:solidFill>
-            <a:srgbClr val="0D1A26"/>
+              <a:t>Keyword search
+matches title &amp; summary</a:t>
+            </a:r>
+          </a:p>
+        </p:txBody>
+      </p:sp>
+      <p:sp>
+        <p:nvSpPr>
+          <p:cNvPr id="13" name="Rectangle 12"/>
+          <p:cNvSpPr/>
+          <p:nvPr/>
+        </p:nvSpPr>
+        <p:spPr>
+          <a:xfrm>
+            <a:off x="8257032" y="2231136"/>
+            <a:ext cx="2596896" cy="749808"/>
+          </a:xfrm>
+          <a:prstGeom prst="rect">
+            <a:avLst/>
+          </a:prstGeom>
+          <a:solidFill>
+            <a:srgbClr val="1A2A3E"/>
           </a:solidFill>
           <a:ln>
             <a:noFill/>
@@ -16289,14 +17144,57 @@
       </p:sp>
       <p:sp>
         <p:nvSpPr>
-          <p:cNvPr id="12" name="TextBox 11"/>
+          <p:cNvPr id="14" name="Rectangle 13"/>
+          <p:cNvSpPr/>
+          <p:nvPr/>
+        </p:nvSpPr>
+        <p:spPr>
+          <a:xfrm>
+            <a:off x="8257032" y="2231136"/>
+            <a:ext cx="36576" cy="749808"/>
+          </a:xfrm>
+          <a:prstGeom prst="rect">
+            <a:avLst/>
+          </a:prstGeom>
+          <a:solidFill>
+            <a:srgbClr val="FF9900"/>
+          </a:solidFill>
+          <a:ln>
+            <a:noFill/>
+          </a:ln>
+        </p:spPr>
+        <p:style>
+          <a:lnRef idx="1">
+            <a:schemeClr val="accent1"/>
+          </a:lnRef>
+          <a:fillRef idx="3">
+            <a:schemeClr val="accent1"/>
+          </a:fillRef>
+          <a:effectRef idx="2">
+            <a:schemeClr val="accent1"/>
+          </a:effectRef>
+          <a:fontRef idx="minor">
+            <a:schemeClr val="lt1"/>
+          </a:fontRef>
+        </p:style>
+        <p:txBody>
+          <a:bodyPr rtlCol="0" anchor="ctr"/>
+          <a:lstStyle/>
+          <a:p>
+            <a:pPr algn="ctr"/>
+          </a:p>
+        </p:txBody>
+      </p:sp>
+      <p:sp>
+        <p:nvSpPr>
+          <p:cNvPr id="15" name="TextBox 14"/>
           <p:cNvSpPr txBox="1"/>
           <p:nvPr/>
         </p:nvSpPr>
         <p:spPr>
           <a:xfrm>
-            <a:off x="420624" y="1783080"/>
-            <a:ext cx="2487168" cy="219456"/>
+            <a:off x="8348472" y="2322576"/>
+            <a:ext cx="2468880" cy="594360"/>
           </a:xfrm>
           <a:prstGeom prst="rect">
             <a:avLst/>
@@ -16311,32 +17209,33 @@
           <a:p>
             <a:pPr algn="l"/>
             <a:r>
-              <a:rPr sz="900" b="0" i="0">
-                <a:solidFill>
-                  <a:srgbClr val="FF9900"/>
+              <a:rPr sz="1000" b="0" i="0">
+                <a:solidFill>
+                  <a:srgbClr val="E2E8F0"/>
                 </a:solidFill>
               </a:rPr>
-              <a:t>▶  Real-time result count</a:t>
-            </a:r>
-          </a:p>
-        </p:txBody>
-      </p:sp>
-      <p:sp>
-        <p:nvSpPr>
-          <p:cNvPr id="13" name="Rectangle 12"/>
-          <p:cNvSpPr/>
-          <p:nvPr/>
-        </p:nvSpPr>
-        <p:spPr>
-          <a:xfrm>
-            <a:off x="8549640" y="932688"/>
-            <a:ext cx="2606040" cy="292608"/>
-          </a:xfrm>
-          <a:prstGeom prst="rect">
-            <a:avLst/>
-          </a:prstGeom>
-          <a:solidFill>
-            <a:srgbClr val="0D1A26"/>
+              <a:t>Active filter pills
+shown in header</a:t>
+            </a:r>
+          </a:p>
+        </p:txBody>
+      </p:sp>
+      <p:sp>
+        <p:nvSpPr>
+          <p:cNvPr id="16" name="Rectangle 15"/>
+          <p:cNvSpPr/>
+          <p:nvPr/>
+        </p:nvSpPr>
+        <p:spPr>
+          <a:xfrm>
+            <a:off x="8257032" y="3090672"/>
+            <a:ext cx="2596896" cy="749808"/>
+          </a:xfrm>
+          <a:prstGeom prst="rect">
+            <a:avLst/>
+          </a:prstGeom>
+          <a:solidFill>
+            <a:srgbClr val="1A2A3E"/>
           </a:solidFill>
           <a:ln>
             <a:noFill/>
@@ -16366,14 +17265,57 @@
       </p:sp>
       <p:sp>
         <p:nvSpPr>
-          <p:cNvPr id="14" name="TextBox 13"/>
+          <p:cNvPr id="17" name="Rectangle 16"/>
+          <p:cNvSpPr/>
+          <p:nvPr/>
+        </p:nvSpPr>
+        <p:spPr>
+          <a:xfrm>
+            <a:off x="8257032" y="3090672"/>
+            <a:ext cx="36576" cy="749808"/>
+          </a:xfrm>
+          <a:prstGeom prst="rect">
+            <a:avLst/>
+          </a:prstGeom>
+          <a:solidFill>
+            <a:srgbClr val="FF9900"/>
+          </a:solidFill>
+          <a:ln>
+            <a:noFill/>
+          </a:ln>
+        </p:spPr>
+        <p:style>
+          <a:lnRef idx="1">
+            <a:schemeClr val="accent1"/>
+          </a:lnRef>
+          <a:fillRef idx="3">
+            <a:schemeClr val="accent1"/>
+          </a:fillRef>
+          <a:effectRef idx="2">
+            <a:schemeClr val="accent1"/>
+          </a:effectRef>
+          <a:fontRef idx="minor">
+            <a:schemeClr val="lt1"/>
+          </a:fontRef>
+        </p:style>
+        <p:txBody>
+          <a:bodyPr rtlCol="0" anchor="ctr"/>
+          <a:lstStyle/>
+          <a:p>
+            <a:pPr algn="ctr"/>
+          </a:p>
+        </p:txBody>
+      </p:sp>
+      <p:sp>
+        <p:nvSpPr>
+          <p:cNvPr id="18" name="TextBox 17"/>
           <p:cNvSpPr txBox="1"/>
           <p:nvPr/>
         </p:nvSpPr>
         <p:spPr>
           <a:xfrm>
-            <a:off x="8622792" y="978408"/>
-            <a:ext cx="2487168" cy="219456"/>
+            <a:off x="8348472" y="3182112"/>
+            <a:ext cx="2468880" cy="594360"/>
           </a:xfrm>
           <a:prstGeom prst="rect">
             <a:avLst/>
@@ -16388,32 +17330,33 @@
           <a:p>
             <a:pPr algn="l"/>
             <a:r>
-              <a:rPr sz="900" b="0" i="0">
-                <a:solidFill>
-                  <a:srgbClr val="FF9900"/>
+              <a:rPr sz="1000" b="0" i="0">
+                <a:solidFill>
+                  <a:srgbClr val="E2E8F0"/>
                 </a:solidFill>
               </a:rPr>
-              <a:t>▶  URL captures all filters — fully shareable</a:t>
-            </a:r>
-          </a:p>
-        </p:txBody>
-      </p:sp>
-      <p:sp>
-        <p:nvSpPr>
-          <p:cNvPr id="15" name="Rectangle 14"/>
-          <p:cNvSpPr/>
-          <p:nvPr/>
-        </p:nvSpPr>
-        <p:spPr>
-          <a:xfrm>
-            <a:off x="8549640" y="1335024"/>
-            <a:ext cx="2606040" cy="292608"/>
-          </a:xfrm>
-          <a:prstGeom prst="rect">
-            <a:avLst/>
-          </a:prstGeom>
-          <a:solidFill>
-            <a:srgbClr val="0D1A26"/>
+              <a:t>Real-time
+result count</a:t>
+            </a:r>
+          </a:p>
+        </p:txBody>
+      </p:sp>
+      <p:sp>
+        <p:nvSpPr>
+          <p:cNvPr id="19" name="Rectangle 18"/>
+          <p:cNvSpPr/>
+          <p:nvPr/>
+        </p:nvSpPr>
+        <p:spPr>
+          <a:xfrm>
+            <a:off x="8257032" y="3950208"/>
+            <a:ext cx="2596896" cy="749808"/>
+          </a:xfrm>
+          <a:prstGeom prst="rect">
+            <a:avLst/>
+          </a:prstGeom>
+          <a:solidFill>
+            <a:srgbClr val="1A2A3E"/>
           </a:solidFill>
           <a:ln>
             <a:noFill/>
@@ -16443,14 +17386,57 @@
       </p:sp>
       <p:sp>
         <p:nvSpPr>
-          <p:cNvPr id="16" name="TextBox 15"/>
+          <p:cNvPr id="20" name="Rectangle 19"/>
+          <p:cNvSpPr/>
+          <p:nvPr/>
+        </p:nvSpPr>
+        <p:spPr>
+          <a:xfrm>
+            <a:off x="8257032" y="3950208"/>
+            <a:ext cx="36576" cy="749808"/>
+          </a:xfrm>
+          <a:prstGeom prst="rect">
+            <a:avLst/>
+          </a:prstGeom>
+          <a:solidFill>
+            <a:srgbClr val="FF9900"/>
+          </a:solidFill>
+          <a:ln>
+            <a:noFill/>
+          </a:ln>
+        </p:spPr>
+        <p:style>
+          <a:lnRef idx="1">
+            <a:schemeClr val="accent1"/>
+          </a:lnRef>
+          <a:fillRef idx="3">
+            <a:schemeClr val="accent1"/>
+          </a:fillRef>
+          <a:effectRef idx="2">
+            <a:schemeClr val="accent1"/>
+          </a:effectRef>
+          <a:fontRef idx="minor">
+            <a:schemeClr val="lt1"/>
+          </a:fontRef>
+        </p:style>
+        <p:txBody>
+          <a:bodyPr rtlCol="0" anchor="ctr"/>
+          <a:lstStyle/>
+          <a:p>
+            <a:pPr algn="ctr"/>
+          </a:p>
+        </p:txBody>
+      </p:sp>
+      <p:sp>
+        <p:nvSpPr>
+          <p:cNvPr id="21" name="TextBox 20"/>
           <p:cNvSpPr txBox="1"/>
           <p:nvPr/>
         </p:nvSpPr>
         <p:spPr>
           <a:xfrm>
-            <a:off x="8622792" y="1380744"/>
-            <a:ext cx="2487168" cy="219456"/>
+            <a:off x="8348472" y="4041648"/>
+            <a:ext cx="2468880" cy="594360"/>
           </a:xfrm>
           <a:prstGeom prst="rect">
             <a:avLst/>
@@ -16465,32 +17451,33 @@
           <a:p>
             <a:pPr algn="l"/>
             <a:r>
-              <a:rPr sz="900" b="0" i="0">
-                <a:solidFill>
-                  <a:srgbClr val="FF9900"/>
+              <a:rPr sz="1000" b="0" i="0">
+                <a:solidFill>
+                  <a:srgbClr val="E2E8F0"/>
                 </a:solidFill>
               </a:rPr>
-              <a:t>▶  Infinite scroll auto-loads next page</a:t>
-            </a:r>
-          </a:p>
-        </p:txBody>
-      </p:sp>
-      <p:sp>
-        <p:nvSpPr>
-          <p:cNvPr id="17" name="Rectangle 16"/>
-          <p:cNvSpPr/>
-          <p:nvPr/>
-        </p:nvSpPr>
-        <p:spPr>
-          <a:xfrm>
-            <a:off x="8549640" y="1737360"/>
-            <a:ext cx="2606040" cy="292608"/>
-          </a:xfrm>
-          <a:prstGeom prst="rect">
-            <a:avLst/>
-          </a:prstGeom>
-          <a:solidFill>
-            <a:srgbClr val="0D1A26"/>
+              <a:t>URL captures all
+filters — shareable</a:t>
+            </a:r>
+          </a:p>
+        </p:txBody>
+      </p:sp>
+      <p:sp>
+        <p:nvSpPr>
+          <p:cNvPr id="22" name="Rectangle 21"/>
+          <p:cNvSpPr/>
+          <p:nvPr/>
+        </p:nvSpPr>
+        <p:spPr>
+          <a:xfrm>
+            <a:off x="8257032" y="4809744"/>
+            <a:ext cx="2596896" cy="749808"/>
+          </a:xfrm>
+          <a:prstGeom prst="rect">
+            <a:avLst/>
+          </a:prstGeom>
+          <a:solidFill>
+            <a:srgbClr val="1A2A3E"/>
           </a:solidFill>
           <a:ln>
             <a:noFill/>
@@ -16520,14 +17507,57 @@
       </p:sp>
       <p:sp>
         <p:nvSpPr>
-          <p:cNvPr id="18" name="TextBox 17"/>
+          <p:cNvPr id="23" name="Rectangle 22"/>
+          <p:cNvSpPr/>
+          <p:nvPr/>
+        </p:nvSpPr>
+        <p:spPr>
+          <a:xfrm>
+            <a:off x="8257032" y="4809744"/>
+            <a:ext cx="36576" cy="749808"/>
+          </a:xfrm>
+          <a:prstGeom prst="rect">
+            <a:avLst/>
+          </a:prstGeom>
+          <a:solidFill>
+            <a:srgbClr val="FF9900"/>
+          </a:solidFill>
+          <a:ln>
+            <a:noFill/>
+          </a:ln>
+        </p:spPr>
+        <p:style>
+          <a:lnRef idx="1">
+            <a:schemeClr val="accent1"/>
+          </a:lnRef>
+          <a:fillRef idx="3">
+            <a:schemeClr val="accent1"/>
+          </a:fillRef>
+          <a:effectRef idx="2">
+            <a:schemeClr val="accent1"/>
+          </a:effectRef>
+          <a:fontRef idx="minor">
+            <a:schemeClr val="lt1"/>
+          </a:fontRef>
+        </p:style>
+        <p:txBody>
+          <a:bodyPr rtlCol="0" anchor="ctr"/>
+          <a:lstStyle/>
+          <a:p>
+            <a:pPr algn="ctr"/>
+          </a:p>
+        </p:txBody>
+      </p:sp>
+      <p:sp>
+        <p:nvSpPr>
+          <p:cNvPr id="24" name="TextBox 23"/>
           <p:cNvSpPr txBox="1"/>
           <p:nvPr/>
         </p:nvSpPr>
         <p:spPr>
           <a:xfrm>
-            <a:off x="8622792" y="1783080"/>
-            <a:ext cx="2487168" cy="219456"/>
+            <a:off x="8348472" y="4901184"/>
+            <a:ext cx="2468880" cy="594360"/>
           </a:xfrm>
           <a:prstGeom prst="rect">
             <a:avLst/>
@@ -16542,12 +17572,134 @@
           <a:p>
             <a:pPr algn="l"/>
             <a:r>
-              <a:rPr sz="900" b="0" i="0">
-                <a:solidFill>
-                  <a:srgbClr val="FF9900"/>
+              <a:rPr sz="1000" b="0" i="0">
+                <a:solidFill>
+                  <a:srgbClr val="E2E8F0"/>
                 </a:solidFill>
               </a:rPr>
-              <a:t>▶  Works across all 8 feature type categories</a:t>
+              <a:t>Infinite scroll
+auto-loads next page</a:t>
+            </a:r>
+          </a:p>
+        </p:txBody>
+      </p:sp>
+      <p:sp>
+        <p:nvSpPr>
+          <p:cNvPr id="25" name="Rectangle 24"/>
+          <p:cNvSpPr/>
+          <p:nvPr/>
+        </p:nvSpPr>
+        <p:spPr>
+          <a:xfrm>
+            <a:off x="8257032" y="5669279"/>
+            <a:ext cx="2596896" cy="749808"/>
+          </a:xfrm>
+          <a:prstGeom prst="rect">
+            <a:avLst/>
+          </a:prstGeom>
+          <a:solidFill>
+            <a:srgbClr val="1A2A3E"/>
+          </a:solidFill>
+          <a:ln>
+            <a:noFill/>
+          </a:ln>
+        </p:spPr>
+        <p:style>
+          <a:lnRef idx="1">
+            <a:schemeClr val="accent1"/>
+          </a:lnRef>
+          <a:fillRef idx="3">
+            <a:schemeClr val="accent1"/>
+          </a:fillRef>
+          <a:effectRef idx="2">
+            <a:schemeClr val="accent1"/>
+          </a:effectRef>
+          <a:fontRef idx="minor">
+            <a:schemeClr val="lt1"/>
+          </a:fontRef>
+        </p:style>
+        <p:txBody>
+          <a:bodyPr rtlCol="0" anchor="ctr"/>
+          <a:lstStyle/>
+          <a:p>
+            <a:pPr algn="ctr"/>
+          </a:p>
+        </p:txBody>
+      </p:sp>
+      <p:sp>
+        <p:nvSpPr>
+          <p:cNvPr id="26" name="Rectangle 25"/>
+          <p:cNvSpPr/>
+          <p:nvPr/>
+        </p:nvSpPr>
+        <p:spPr>
+          <a:xfrm>
+            <a:off x="8257032" y="5669279"/>
+            <a:ext cx="36576" cy="749808"/>
+          </a:xfrm>
+          <a:prstGeom prst="rect">
+            <a:avLst/>
+          </a:prstGeom>
+          <a:solidFill>
+            <a:srgbClr val="FF9900"/>
+          </a:solidFill>
+          <a:ln>
+            <a:noFill/>
+          </a:ln>
+        </p:spPr>
+        <p:style>
+          <a:lnRef idx="1">
+            <a:schemeClr val="accent1"/>
+          </a:lnRef>
+          <a:fillRef idx="3">
+            <a:schemeClr val="accent1"/>
+          </a:fillRef>
+          <a:effectRef idx="2">
+            <a:schemeClr val="accent1"/>
+          </a:effectRef>
+          <a:fontRef idx="minor">
+            <a:schemeClr val="lt1"/>
+          </a:fontRef>
+        </p:style>
+        <p:txBody>
+          <a:bodyPr rtlCol="0" anchor="ctr"/>
+          <a:lstStyle/>
+          <a:p>
+            <a:pPr algn="ctr"/>
+          </a:p>
+        </p:txBody>
+      </p:sp>
+      <p:sp>
+        <p:nvSpPr>
+          <p:cNvPr id="27" name="TextBox 26"/>
+          <p:cNvSpPr txBox="1"/>
+          <p:nvPr/>
+        </p:nvSpPr>
+        <p:spPr>
+          <a:xfrm>
+            <a:off x="8348472" y="5760719"/>
+            <a:ext cx="2468880" cy="594360"/>
+          </a:xfrm>
+          <a:prstGeom prst="rect">
+            <a:avLst/>
+          </a:prstGeom>
+          <a:noFill/>
+        </p:spPr>
+        <p:txBody>
+          <a:bodyPr wrap="square">
+            <a:spAutoFit/>
+          </a:bodyPr>
+          <a:lstStyle/>
+          <a:p>
+            <a:pPr algn="l"/>
+            <a:r>
+              <a:rPr sz="1000" b="0" i="0">
+                <a:solidFill>
+                  <a:srgbClr val="E2E8F0"/>
+                </a:solidFill>
+              </a:rPr>
+              <a:t>Works across
+all 8 feature types</a:t>
             </a:r>
           </a:p>
         </p:txBody>

</xml_diff>